<commit_message>
Nova capa da apresentação
</commit_message>
<xml_diff>
--- a/reports/apresentacao/Apresentacao_Projeto1_TechChallenge.pptx
+++ b/reports/apresentacao/Apresentacao_Projeto1_TechChallenge.pptx
@@ -4795,7 +4795,7 @@
         </p:nvSpPr>
         <p:spPr>
           <a:xfrm>
-            <a:off x="731520" y="1051560"/>
+            <a:off x="731520" y="900000"/>
             <a:ext cx="8229600" cy="411480"/>
           </a:xfrm>
           <a:prstGeom prst="rect">
@@ -4833,8 +4833,8 @@
         </p:nvSpPr>
         <p:spPr>
           <a:xfrm>
-            <a:off x="731520" y="1600200"/>
-            <a:ext cx="7680960" cy="2377440"/>
+            <a:off x="731520" y="1300000"/>
+            <a:ext cx="10700000" cy="1700000"/>
           </a:xfrm>
           <a:prstGeom prst="rect">
             <a:avLst/>
@@ -4874,8 +4874,8 @@
         </p:nvSpPr>
         <p:spPr>
           <a:xfrm>
-            <a:off x="731520" y="4114800"/>
-            <a:ext cx="7498080" cy="914400"/>
+            <a:off x="731520" y="3000000"/>
+            <a:ext cx="10700000" cy="500000"/>
           </a:xfrm>
           <a:prstGeom prst="rect">
             <a:avLst/>
@@ -4887,18 +4887,9 @@
           <a:bodyPr wrap="square" lIns="0" tIns="0" rIns="0" bIns="0" rtlCol="0" anchor="t"/>
           <a:lstStyle/>
           <a:p>
-            <a:pPr indent="0" marL="0">
-              <a:buNone/>
-            </a:pPr>
             <a:r>
-              <a:rPr lang="en-US" sz="1800" dirty="0">
-                <a:solidFill>
-                  <a:schemeClr val="bg2"/>
-                </a:solidFill>
-              </a:rPr>
-              <a:t>Relatório executivo para investidores · 100 mil pedidos reais de e-commerce, 2016 a 2018</a:t>
+              <a:t>Relatório executivo para investidores e acionistas · 100 mil pedidos reais de e-commerce, 2016 a 2018</a:t>
             </a:r>
-            <a:endParaRPr lang="en-US" sz="1800" dirty="0"/>
           </a:p>
         </p:txBody>
       </p:sp>
@@ -4912,7 +4903,7 @@
         </p:nvSpPr>
         <p:spPr>
           <a:xfrm>
-            <a:off x="731520" y="5669280"/>
+            <a:off x="731520" y="6000000"/>
             <a:ext cx="8229600" cy="457200"/>
           </a:xfrm>
           <a:prstGeom prst="rect">
@@ -4942,328 +4933,937 @@
       </p:sp>
       <p:sp>
         <p:nvSpPr>
-          <p:cNvPr id="6" name="capa_card0"/>
-          <p:cNvSpPr/>
-          <p:nvPr/>
-        </p:nvSpPr>
-        <p:spPr>
-          <a:xfrm>
-            <a:off x="8915400" y="1417320"/>
-            <a:ext cx="2651760" cy="1234440"/>
-          </a:xfrm>
-          <a:prstGeom prst="roundRect">
-            <a:avLst>
-              <a:gd name="adj" fmla="val 8889"/>
-            </a:avLst>
-          </a:prstGeom>
-          <a:solidFill>
-            <a:schemeClr val="tx2"/>
-          </a:solidFill>
-          <a:ln w="12700">
-            <a:solidFill>
-              <a:schemeClr val="tx2"/>
-            </a:solidFill>
-            <a:prstDash val="solid"/>
+          <p:cNvPr id="6" name="Rectangle 5"/>
+          <p:cNvSpPr/>
+          <p:nvPr/>
+        </p:nvSpPr>
+        <p:spPr>
+          <a:xfrm>
+            <a:off x="731520" y="620000"/>
+            <a:ext cx="640000" cy="60000"/>
+          </a:xfrm>
+          <a:prstGeom prst="rect">
+            <a:avLst/>
+          </a:prstGeom>
+          <a:solidFill>
+            <a:srgbClr val="ED145B"/>
+          </a:solidFill>
+          <a:ln>
+            <a:noFill/>
           </a:ln>
         </p:spPr>
-        <p:txBody>
-          <a:bodyPr/>
-          <a:p/>
-        </p:txBody>
-      </p:sp>
-      <p:sp>
-        <p:nvSpPr>
-          <p:cNvPr id="7" name="capa_num0"/>
+        <p:style>
+          <a:lnRef idx="1">
+            <a:schemeClr val="accent1"/>
+          </a:lnRef>
+          <a:fillRef idx="3">
+            <a:schemeClr val="accent1"/>
+          </a:fillRef>
+          <a:effectRef idx="2">
+            <a:schemeClr val="accent1"/>
+          </a:effectRef>
+          <a:fontRef idx="minor">
+            <a:schemeClr val="lt1"/>
+          </a:fontRef>
+        </p:style>
+        <p:txBody>
+          <a:bodyPr rtlCol="0" anchor="ctr"/>
+          <a:lstStyle/>
+          <a:p>
+            <a:pPr algn="ctr"/>
+          </a:p>
+        </p:txBody>
+      </p:sp>
+      <p:sp>
+        <p:nvSpPr>
+          <p:cNvPr id="7" name="Rectangle 6"/>
+          <p:cNvSpPr/>
+          <p:nvPr/>
+        </p:nvSpPr>
+        <p:spPr>
+          <a:xfrm>
+            <a:off x="731520" y="5241908"/>
+            <a:ext cx="450924" cy="208092"/>
+          </a:xfrm>
+          <a:prstGeom prst="rect">
+            <a:avLst/>
+          </a:prstGeom>
+          <a:solidFill>
+            <a:srgbClr val="4A4A4A"/>
+          </a:solidFill>
+          <a:ln>
+            <a:noFill/>
+          </a:ln>
+        </p:spPr>
+        <p:style>
+          <a:lnRef idx="1">
+            <a:schemeClr val="accent1"/>
+          </a:lnRef>
+          <a:fillRef idx="3">
+            <a:schemeClr val="accent1"/>
+          </a:fillRef>
+          <a:effectRef idx="2">
+            <a:schemeClr val="accent1"/>
+          </a:effectRef>
+          <a:fontRef idx="minor">
+            <a:schemeClr val="lt1"/>
+          </a:fontRef>
+        </p:style>
+        <p:txBody>
+          <a:bodyPr rtlCol="0" anchor="ctr"/>
+          <a:lstStyle/>
+          <a:p>
+            <a:pPr algn="ctr"/>
+          </a:p>
+        </p:txBody>
+      </p:sp>
+      <p:sp>
+        <p:nvSpPr>
+          <p:cNvPr id="8" name="Rectangle 7"/>
+          <p:cNvSpPr/>
+          <p:nvPr/>
+        </p:nvSpPr>
+        <p:spPr>
+          <a:xfrm>
+            <a:off x="1272444" y="5019365"/>
+            <a:ext cx="450924" cy="430635"/>
+          </a:xfrm>
+          <a:prstGeom prst="rect">
+            <a:avLst/>
+          </a:prstGeom>
+          <a:solidFill>
+            <a:srgbClr val="4A4A4A"/>
+          </a:solidFill>
+          <a:ln>
+            <a:noFill/>
+          </a:ln>
+        </p:spPr>
+        <p:style>
+          <a:lnRef idx="1">
+            <a:schemeClr val="accent1"/>
+          </a:lnRef>
+          <a:fillRef idx="3">
+            <a:schemeClr val="accent1"/>
+          </a:fillRef>
+          <a:effectRef idx="2">
+            <a:schemeClr val="accent1"/>
+          </a:effectRef>
+          <a:fontRef idx="minor">
+            <a:schemeClr val="lt1"/>
+          </a:fontRef>
+        </p:style>
+        <p:txBody>
+          <a:bodyPr rtlCol="0" anchor="ctr"/>
+          <a:lstStyle/>
+          <a:p>
+            <a:pPr algn="ctr"/>
+          </a:p>
+        </p:txBody>
+      </p:sp>
+      <p:sp>
+        <p:nvSpPr>
+          <p:cNvPr id="9" name="Rectangle 8"/>
+          <p:cNvSpPr/>
+          <p:nvPr/>
+        </p:nvSpPr>
+        <p:spPr>
+          <a:xfrm>
+            <a:off x="1813368" y="4805492"/>
+            <a:ext cx="450924" cy="644508"/>
+          </a:xfrm>
+          <a:prstGeom prst="rect">
+            <a:avLst/>
+          </a:prstGeom>
+          <a:solidFill>
+            <a:srgbClr val="4A4A4A"/>
+          </a:solidFill>
+          <a:ln>
+            <a:noFill/>
+          </a:ln>
+        </p:spPr>
+        <p:style>
+          <a:lnRef idx="1">
+            <a:schemeClr val="accent1"/>
+          </a:lnRef>
+          <a:fillRef idx="3">
+            <a:schemeClr val="accent1"/>
+          </a:fillRef>
+          <a:effectRef idx="2">
+            <a:schemeClr val="accent1"/>
+          </a:effectRef>
+          <a:fontRef idx="minor">
+            <a:schemeClr val="lt1"/>
+          </a:fontRef>
+        </p:style>
+        <p:txBody>
+          <a:bodyPr rtlCol="0" anchor="ctr"/>
+          <a:lstStyle/>
+          <a:p>
+            <a:pPr algn="ctr"/>
+          </a:p>
+        </p:txBody>
+      </p:sp>
+      <p:sp>
+        <p:nvSpPr>
+          <p:cNvPr id="10" name="Rectangle 9"/>
+          <p:cNvSpPr/>
+          <p:nvPr/>
+        </p:nvSpPr>
+        <p:spPr>
+          <a:xfrm>
+            <a:off x="2354292" y="4835839"/>
+            <a:ext cx="450924" cy="614161"/>
+          </a:xfrm>
+          <a:prstGeom prst="rect">
+            <a:avLst/>
+          </a:prstGeom>
+          <a:solidFill>
+            <a:srgbClr val="4A4A4A"/>
+          </a:solidFill>
+          <a:ln>
+            <a:noFill/>
+          </a:ln>
+        </p:spPr>
+        <p:style>
+          <a:lnRef idx="1">
+            <a:schemeClr val="accent1"/>
+          </a:lnRef>
+          <a:fillRef idx="3">
+            <a:schemeClr val="accent1"/>
+          </a:fillRef>
+          <a:effectRef idx="2">
+            <a:schemeClr val="accent1"/>
+          </a:effectRef>
+          <a:fontRef idx="minor">
+            <a:schemeClr val="lt1"/>
+          </a:fontRef>
+        </p:style>
+        <p:txBody>
+          <a:bodyPr rtlCol="0" anchor="ctr"/>
+          <a:lstStyle/>
+          <a:p>
+            <a:pPr algn="ctr"/>
+          </a:p>
+        </p:txBody>
+      </p:sp>
+      <p:sp>
+        <p:nvSpPr>
+          <p:cNvPr id="11" name="Rectangle 10"/>
+          <p:cNvSpPr/>
+          <p:nvPr/>
+        </p:nvSpPr>
+        <p:spPr>
+          <a:xfrm>
+            <a:off x="2895216" y="4571388"/>
+            <a:ext cx="450924" cy="878612"/>
+          </a:xfrm>
+          <a:prstGeom prst="rect">
+            <a:avLst/>
+          </a:prstGeom>
+          <a:solidFill>
+            <a:srgbClr val="4A4A4A"/>
+          </a:solidFill>
+          <a:ln>
+            <a:noFill/>
+          </a:ln>
+        </p:spPr>
+        <p:style>
+          <a:lnRef idx="1">
+            <a:schemeClr val="accent1"/>
+          </a:lnRef>
+          <a:fillRef idx="3">
+            <a:schemeClr val="accent1"/>
+          </a:fillRef>
+          <a:effectRef idx="2">
+            <a:schemeClr val="accent1"/>
+          </a:effectRef>
+          <a:fontRef idx="minor">
+            <a:schemeClr val="lt1"/>
+          </a:fontRef>
+        </p:style>
+        <p:txBody>
+          <a:bodyPr rtlCol="0" anchor="ctr"/>
+          <a:lstStyle/>
+          <a:p>
+            <a:pPr algn="ctr"/>
+          </a:p>
+        </p:txBody>
+      </p:sp>
+      <p:sp>
+        <p:nvSpPr>
+          <p:cNvPr id="12" name="Rectangle 11"/>
+          <p:cNvSpPr/>
+          <p:nvPr/>
+        </p:nvSpPr>
+        <p:spPr>
+          <a:xfrm>
+            <a:off x="3436140" y="4694220"/>
+            <a:ext cx="450924" cy="755780"/>
+          </a:xfrm>
+          <a:prstGeom prst="rect">
+            <a:avLst/>
+          </a:prstGeom>
+          <a:solidFill>
+            <a:srgbClr val="4A4A4A"/>
+          </a:solidFill>
+          <a:ln>
+            <a:noFill/>
+          </a:ln>
+        </p:spPr>
+        <p:style>
+          <a:lnRef idx="1">
+            <a:schemeClr val="accent1"/>
+          </a:lnRef>
+          <a:fillRef idx="3">
+            <a:schemeClr val="accent1"/>
+          </a:fillRef>
+          <a:effectRef idx="2">
+            <a:schemeClr val="accent1"/>
+          </a:effectRef>
+          <a:fontRef idx="minor">
+            <a:schemeClr val="lt1"/>
+          </a:fontRef>
+        </p:style>
+        <p:txBody>
+          <a:bodyPr rtlCol="0" anchor="ctr"/>
+          <a:lstStyle/>
+          <a:p>
+            <a:pPr algn="ctr"/>
+          </a:p>
+        </p:txBody>
+      </p:sp>
+      <p:sp>
+        <p:nvSpPr>
+          <p:cNvPr id="13" name="Rectangle 12"/>
+          <p:cNvSpPr/>
+          <p:nvPr/>
+        </p:nvSpPr>
+        <p:spPr>
+          <a:xfrm>
+            <a:off x="3977064" y="4577168"/>
+            <a:ext cx="450924" cy="872832"/>
+          </a:xfrm>
+          <a:prstGeom prst="rect">
+            <a:avLst/>
+          </a:prstGeom>
+          <a:solidFill>
+            <a:srgbClr val="4A4A4A"/>
+          </a:solidFill>
+          <a:ln>
+            <a:noFill/>
+          </a:ln>
+        </p:spPr>
+        <p:style>
+          <a:lnRef idx="1">
+            <a:schemeClr val="accent1"/>
+          </a:lnRef>
+          <a:fillRef idx="3">
+            <a:schemeClr val="accent1"/>
+          </a:fillRef>
+          <a:effectRef idx="2">
+            <a:schemeClr val="accent1"/>
+          </a:effectRef>
+          <a:fontRef idx="minor">
+            <a:schemeClr val="lt1"/>
+          </a:fontRef>
+        </p:style>
+        <p:txBody>
+          <a:bodyPr rtlCol="0" anchor="ctr"/>
+          <a:lstStyle/>
+          <a:p>
+            <a:pPr algn="ctr"/>
+          </a:p>
+        </p:txBody>
+      </p:sp>
+      <p:sp>
+        <p:nvSpPr>
+          <p:cNvPr id="14" name="Rectangle 13"/>
+          <p:cNvSpPr/>
+          <p:nvPr/>
+        </p:nvSpPr>
+        <p:spPr>
+          <a:xfrm>
+            <a:off x="4517988" y="4452891"/>
+            <a:ext cx="450924" cy="997109"/>
+          </a:xfrm>
+          <a:prstGeom prst="rect">
+            <a:avLst/>
+          </a:prstGeom>
+          <a:solidFill>
+            <a:srgbClr val="4A4A4A"/>
+          </a:solidFill>
+          <a:ln>
+            <a:noFill/>
+          </a:ln>
+        </p:spPr>
+        <p:style>
+          <a:lnRef idx="1">
+            <a:schemeClr val="accent1"/>
+          </a:lnRef>
+          <a:fillRef idx="3">
+            <a:schemeClr val="accent1"/>
+          </a:fillRef>
+          <a:effectRef idx="2">
+            <a:schemeClr val="accent1"/>
+          </a:effectRef>
+          <a:fontRef idx="minor">
+            <a:schemeClr val="lt1"/>
+          </a:fontRef>
+        </p:style>
+        <p:txBody>
+          <a:bodyPr rtlCol="0" anchor="ctr"/>
+          <a:lstStyle/>
+          <a:p>
+            <a:pPr algn="ctr"/>
+          </a:p>
+        </p:txBody>
+      </p:sp>
+      <p:sp>
+        <p:nvSpPr>
+          <p:cNvPr id="15" name="Rectangle 14"/>
+          <p:cNvSpPr/>
+          <p:nvPr/>
+        </p:nvSpPr>
+        <p:spPr>
+          <a:xfrm>
+            <a:off x="5058912" y="4371966"/>
+            <a:ext cx="450924" cy="1078034"/>
+          </a:xfrm>
+          <a:prstGeom prst="rect">
+            <a:avLst/>
+          </a:prstGeom>
+          <a:solidFill>
+            <a:srgbClr val="4A4A4A"/>
+          </a:solidFill>
+          <a:ln>
+            <a:noFill/>
+          </a:ln>
+        </p:spPr>
+        <p:style>
+          <a:lnRef idx="1">
+            <a:schemeClr val="accent1"/>
+          </a:lnRef>
+          <a:fillRef idx="3">
+            <a:schemeClr val="accent1"/>
+          </a:fillRef>
+          <a:effectRef idx="2">
+            <a:schemeClr val="accent1"/>
+          </a:effectRef>
+          <a:fontRef idx="minor">
+            <a:schemeClr val="lt1"/>
+          </a:fontRef>
+        </p:style>
+        <p:txBody>
+          <a:bodyPr rtlCol="0" anchor="ctr"/>
+          <a:lstStyle/>
+          <a:p>
+            <a:pPr algn="ctr"/>
+          </a:p>
+        </p:txBody>
+      </p:sp>
+      <p:sp>
+        <p:nvSpPr>
+          <p:cNvPr id="16" name="Rectangle 15"/>
+          <p:cNvSpPr/>
+          <p:nvPr/>
+        </p:nvSpPr>
+        <p:spPr>
+          <a:xfrm>
+            <a:off x="5599836" y="4305492"/>
+            <a:ext cx="450924" cy="1144508"/>
+          </a:xfrm>
+          <a:prstGeom prst="rect">
+            <a:avLst/>
+          </a:prstGeom>
+          <a:solidFill>
+            <a:srgbClr val="4A4A4A"/>
+          </a:solidFill>
+          <a:ln>
+            <a:noFill/>
+          </a:ln>
+        </p:spPr>
+        <p:style>
+          <a:lnRef idx="1">
+            <a:schemeClr val="accent1"/>
+          </a:lnRef>
+          <a:fillRef idx="3">
+            <a:schemeClr val="accent1"/>
+          </a:fillRef>
+          <a:effectRef idx="2">
+            <a:schemeClr val="accent1"/>
+          </a:effectRef>
+          <a:fontRef idx="minor">
+            <a:schemeClr val="lt1"/>
+          </a:fontRef>
+        </p:style>
+        <p:txBody>
+          <a:bodyPr rtlCol="0" anchor="ctr"/>
+          <a:lstStyle/>
+          <a:p>
+            <a:pPr algn="ctr"/>
+          </a:p>
+        </p:txBody>
+      </p:sp>
+      <p:sp>
+        <p:nvSpPr>
+          <p:cNvPr id="17" name="Rectangle 16"/>
+          <p:cNvSpPr/>
+          <p:nvPr/>
+        </p:nvSpPr>
+        <p:spPr>
+          <a:xfrm>
+            <a:off x="6140760" y="3700000"/>
+            <a:ext cx="450924" cy="1750000"/>
+          </a:xfrm>
+          <a:prstGeom prst="rect">
+            <a:avLst/>
+          </a:prstGeom>
+          <a:solidFill>
+            <a:srgbClr val="4A4A4A"/>
+          </a:solidFill>
+          <a:ln>
+            <a:noFill/>
+          </a:ln>
+        </p:spPr>
+        <p:style>
+          <a:lnRef idx="1">
+            <a:schemeClr val="accent1"/>
+          </a:lnRef>
+          <a:fillRef idx="3">
+            <a:schemeClr val="accent1"/>
+          </a:fillRef>
+          <a:effectRef idx="2">
+            <a:schemeClr val="accent1"/>
+          </a:effectRef>
+          <a:fontRef idx="minor">
+            <a:schemeClr val="lt1"/>
+          </a:fontRef>
+        </p:style>
+        <p:txBody>
+          <a:bodyPr rtlCol="0" anchor="ctr"/>
+          <a:lstStyle/>
+          <a:p>
+            <a:pPr algn="ctr"/>
+          </a:p>
+        </p:txBody>
+      </p:sp>
+      <p:sp>
+        <p:nvSpPr>
+          <p:cNvPr id="18" name="Rectangle 17"/>
+          <p:cNvSpPr/>
+          <p:nvPr/>
+        </p:nvSpPr>
+        <p:spPr>
+          <a:xfrm>
+            <a:off x="6681684" y="4169654"/>
+            <a:ext cx="450924" cy="1280346"/>
+          </a:xfrm>
+          <a:prstGeom prst="rect">
+            <a:avLst/>
+          </a:prstGeom>
+          <a:solidFill>
+            <a:srgbClr val="4A4A4A"/>
+          </a:solidFill>
+          <a:ln>
+            <a:noFill/>
+          </a:ln>
+        </p:spPr>
+        <p:style>
+          <a:lnRef idx="1">
+            <a:schemeClr val="accent1"/>
+          </a:lnRef>
+          <a:fillRef idx="3">
+            <a:schemeClr val="accent1"/>
+          </a:fillRef>
+          <a:effectRef idx="2">
+            <a:schemeClr val="accent1"/>
+          </a:effectRef>
+          <a:fontRef idx="minor">
+            <a:schemeClr val="lt1"/>
+          </a:fontRef>
+        </p:style>
+        <p:txBody>
+          <a:bodyPr rtlCol="0" anchor="ctr"/>
+          <a:lstStyle/>
+          <a:p>
+            <a:pPr algn="ctr"/>
+          </a:p>
+        </p:txBody>
+      </p:sp>
+      <p:sp>
+        <p:nvSpPr>
+          <p:cNvPr id="19" name="Rectangle 18"/>
+          <p:cNvSpPr/>
+          <p:nvPr/>
+        </p:nvSpPr>
+        <p:spPr>
+          <a:xfrm>
+            <a:off x="7222608" y="3817053"/>
+            <a:ext cx="450924" cy="1632947"/>
+          </a:xfrm>
+          <a:prstGeom prst="rect">
+            <a:avLst/>
+          </a:prstGeom>
+          <a:solidFill>
+            <a:srgbClr val="ED145B"/>
+          </a:solidFill>
+          <a:ln>
+            <a:noFill/>
+          </a:ln>
+        </p:spPr>
+        <p:style>
+          <a:lnRef idx="1">
+            <a:schemeClr val="accent1"/>
+          </a:lnRef>
+          <a:fillRef idx="3">
+            <a:schemeClr val="accent1"/>
+          </a:fillRef>
+          <a:effectRef idx="2">
+            <a:schemeClr val="accent1"/>
+          </a:effectRef>
+          <a:fontRef idx="minor">
+            <a:schemeClr val="lt1"/>
+          </a:fontRef>
+        </p:style>
+        <p:txBody>
+          <a:bodyPr rtlCol="0" anchor="ctr"/>
+          <a:lstStyle/>
+          <a:p>
+            <a:pPr algn="ctr"/>
+          </a:p>
+        </p:txBody>
+      </p:sp>
+      <p:sp>
+        <p:nvSpPr>
+          <p:cNvPr id="20" name="Rectangle 19"/>
+          <p:cNvSpPr/>
+          <p:nvPr/>
+        </p:nvSpPr>
+        <p:spPr>
+          <a:xfrm>
+            <a:off x="7763532" y="4003469"/>
+            <a:ext cx="450924" cy="1446531"/>
+          </a:xfrm>
+          <a:prstGeom prst="rect">
+            <a:avLst/>
+          </a:prstGeom>
+          <a:solidFill>
+            <a:srgbClr val="ED145B"/>
+          </a:solidFill>
+          <a:ln>
+            <a:noFill/>
+          </a:ln>
+        </p:spPr>
+        <p:style>
+          <a:lnRef idx="1">
+            <a:schemeClr val="accent1"/>
+          </a:lnRef>
+          <a:fillRef idx="3">
+            <a:schemeClr val="accent1"/>
+          </a:fillRef>
+          <a:effectRef idx="2">
+            <a:schemeClr val="accent1"/>
+          </a:effectRef>
+          <a:fontRef idx="minor">
+            <a:schemeClr val="lt1"/>
+          </a:fontRef>
+        </p:style>
+        <p:txBody>
+          <a:bodyPr rtlCol="0" anchor="ctr"/>
+          <a:lstStyle/>
+          <a:p>
+            <a:pPr algn="ctr"/>
+          </a:p>
+        </p:txBody>
+      </p:sp>
+      <p:sp>
+        <p:nvSpPr>
+          <p:cNvPr id="21" name="Rectangle 20"/>
+          <p:cNvSpPr/>
+          <p:nvPr/>
+        </p:nvSpPr>
+        <p:spPr>
+          <a:xfrm>
+            <a:off x="8304456" y="3749133"/>
+            <a:ext cx="450924" cy="1700867"/>
+          </a:xfrm>
+          <a:prstGeom prst="rect">
+            <a:avLst/>
+          </a:prstGeom>
+          <a:solidFill>
+            <a:srgbClr val="ED145B"/>
+          </a:solidFill>
+          <a:ln>
+            <a:noFill/>
+          </a:ln>
+        </p:spPr>
+        <p:style>
+          <a:lnRef idx="1">
+            <a:schemeClr val="accent1"/>
+          </a:lnRef>
+          <a:fillRef idx="3">
+            <a:schemeClr val="accent1"/>
+          </a:fillRef>
+          <a:effectRef idx="2">
+            <a:schemeClr val="accent1"/>
+          </a:effectRef>
+          <a:fontRef idx="minor">
+            <a:schemeClr val="lt1"/>
+          </a:fontRef>
+        </p:style>
+        <p:txBody>
+          <a:bodyPr rtlCol="0" anchor="ctr"/>
+          <a:lstStyle/>
+          <a:p>
+            <a:pPr algn="ctr"/>
+          </a:p>
+        </p:txBody>
+      </p:sp>
+      <p:sp>
+        <p:nvSpPr>
+          <p:cNvPr id="22" name="Rectangle 21"/>
+          <p:cNvSpPr/>
+          <p:nvPr/>
+        </p:nvSpPr>
+        <p:spPr>
+          <a:xfrm>
+            <a:off x="8845380" y="3747688"/>
+            <a:ext cx="450924" cy="1702312"/>
+          </a:xfrm>
+          <a:prstGeom prst="rect">
+            <a:avLst/>
+          </a:prstGeom>
+          <a:solidFill>
+            <a:srgbClr val="ED145B"/>
+          </a:solidFill>
+          <a:ln>
+            <a:noFill/>
+          </a:ln>
+        </p:spPr>
+        <p:style>
+          <a:lnRef idx="1">
+            <a:schemeClr val="accent1"/>
+          </a:lnRef>
+          <a:fillRef idx="3">
+            <a:schemeClr val="accent1"/>
+          </a:fillRef>
+          <a:effectRef idx="2">
+            <a:schemeClr val="accent1"/>
+          </a:effectRef>
+          <a:fontRef idx="minor">
+            <a:schemeClr val="lt1"/>
+          </a:fontRef>
+        </p:style>
+        <p:txBody>
+          <a:bodyPr rtlCol="0" anchor="ctr"/>
+          <a:lstStyle/>
+          <a:p>
+            <a:pPr algn="ctr"/>
+          </a:p>
+        </p:txBody>
+      </p:sp>
+      <p:sp>
+        <p:nvSpPr>
+          <p:cNvPr id="23" name="Rectangle 22"/>
+          <p:cNvSpPr/>
+          <p:nvPr/>
+        </p:nvSpPr>
+        <p:spPr>
+          <a:xfrm>
+            <a:off x="9386304" y="3769365"/>
+            <a:ext cx="450924" cy="1680635"/>
+          </a:xfrm>
+          <a:prstGeom prst="rect">
+            <a:avLst/>
+          </a:prstGeom>
+          <a:solidFill>
+            <a:srgbClr val="ED145B"/>
+          </a:solidFill>
+          <a:ln>
+            <a:noFill/>
+          </a:ln>
+        </p:spPr>
+        <p:style>
+          <a:lnRef idx="1">
+            <a:schemeClr val="accent1"/>
+          </a:lnRef>
+          <a:fillRef idx="3">
+            <a:schemeClr val="accent1"/>
+          </a:fillRef>
+          <a:effectRef idx="2">
+            <a:schemeClr val="accent1"/>
+          </a:effectRef>
+          <a:fontRef idx="minor">
+            <a:schemeClr val="lt1"/>
+          </a:fontRef>
+        </p:style>
+        <p:txBody>
+          <a:bodyPr rtlCol="0" anchor="ctr"/>
+          <a:lstStyle/>
+          <a:p>
+            <a:pPr algn="ctr"/>
+          </a:p>
+        </p:txBody>
+      </p:sp>
+      <p:sp>
+        <p:nvSpPr>
+          <p:cNvPr id="24" name="Rectangle 23"/>
+          <p:cNvSpPr/>
+          <p:nvPr/>
+        </p:nvSpPr>
+        <p:spPr>
+          <a:xfrm>
+            <a:off x="9927228" y="3971677"/>
+            <a:ext cx="450924" cy="1478323"/>
+          </a:xfrm>
+          <a:prstGeom prst="rect">
+            <a:avLst/>
+          </a:prstGeom>
+          <a:solidFill>
+            <a:srgbClr val="ED145B"/>
+          </a:solidFill>
+          <a:ln>
+            <a:noFill/>
+          </a:ln>
+        </p:spPr>
+        <p:style>
+          <a:lnRef idx="1">
+            <a:schemeClr val="accent1"/>
+          </a:lnRef>
+          <a:fillRef idx="3">
+            <a:schemeClr val="accent1"/>
+          </a:fillRef>
+          <a:effectRef idx="2">
+            <a:schemeClr val="accent1"/>
+          </a:effectRef>
+          <a:fontRef idx="minor">
+            <a:schemeClr val="lt1"/>
+          </a:fontRef>
+        </p:style>
+        <p:txBody>
+          <a:bodyPr rtlCol="0" anchor="ctr"/>
+          <a:lstStyle/>
+          <a:p>
+            <a:pPr algn="ctr"/>
+          </a:p>
+        </p:txBody>
+      </p:sp>
+      <p:sp>
+        <p:nvSpPr>
+          <p:cNvPr id="25" name="Rectangle 24"/>
+          <p:cNvSpPr/>
+          <p:nvPr/>
+        </p:nvSpPr>
+        <p:spPr>
+          <a:xfrm>
+            <a:off x="10468152" y="3948555"/>
+            <a:ext cx="450924" cy="1501445"/>
+          </a:xfrm>
+          <a:prstGeom prst="rect">
+            <a:avLst/>
+          </a:prstGeom>
+          <a:solidFill>
+            <a:srgbClr val="ED145B"/>
+          </a:solidFill>
+          <a:ln>
+            <a:noFill/>
+          </a:ln>
+        </p:spPr>
+        <p:style>
+          <a:lnRef idx="1">
+            <a:schemeClr val="accent1"/>
+          </a:lnRef>
+          <a:fillRef idx="3">
+            <a:schemeClr val="accent1"/>
+          </a:fillRef>
+          <a:effectRef idx="2">
+            <a:schemeClr val="accent1"/>
+          </a:effectRef>
+          <a:fontRef idx="minor">
+            <a:schemeClr val="lt1"/>
+          </a:fontRef>
+        </p:style>
+        <p:txBody>
+          <a:bodyPr rtlCol="0" anchor="ctr"/>
+          <a:lstStyle/>
+          <a:p>
+            <a:pPr algn="ctr"/>
+          </a:p>
+        </p:txBody>
+      </p:sp>
+      <p:sp>
+        <p:nvSpPr>
+          <p:cNvPr id="26" name="Rectangle 25"/>
+          <p:cNvSpPr/>
+          <p:nvPr/>
+        </p:nvSpPr>
+        <p:spPr>
+          <a:xfrm>
+            <a:off x="11009076" y="4009249"/>
+            <a:ext cx="450924" cy="1440751"/>
+          </a:xfrm>
+          <a:prstGeom prst="rect">
+            <a:avLst/>
+          </a:prstGeom>
+          <a:solidFill>
+            <a:srgbClr val="ED145B"/>
+          </a:solidFill>
+          <a:ln>
+            <a:noFill/>
+          </a:ln>
+        </p:spPr>
+        <p:style>
+          <a:lnRef idx="1">
+            <a:schemeClr val="accent1"/>
+          </a:lnRef>
+          <a:fillRef idx="3">
+            <a:schemeClr val="accent1"/>
+          </a:fillRef>
+          <a:effectRef idx="2">
+            <a:schemeClr val="accent1"/>
+          </a:effectRef>
+          <a:fontRef idx="minor">
+            <a:schemeClr val="lt1"/>
+          </a:fontRef>
+        </p:style>
+        <p:txBody>
+          <a:bodyPr rtlCol="0" anchor="ctr"/>
+          <a:lstStyle/>
+          <a:p>
+            <a:pPr algn="ctr"/>
+          </a:p>
+        </p:txBody>
+      </p:sp>
+      <p:sp>
+        <p:nvSpPr>
+          <p:cNvPr id="27" name="TextBox 26"/>
           <p:cNvSpPr txBox="1"/>
           <p:nvPr/>
         </p:nvSpPr>
         <p:spPr>
           <a:xfrm>
-            <a:off x="9125712" y="1527048"/>
-            <a:ext cx="2286000" cy="594360"/>
+            <a:off x="731520" y="5490000"/>
+            <a:ext cx="10728480" cy="300000"/>
           </a:xfrm>
           <a:prstGeom prst="rect">
             <a:avLst/>
           </a:prstGeom>
           <a:noFill/>
-          <a:ln/>
-        </p:spPr>
-        <p:txBody>
-          <a:bodyPr wrap="square" lIns="0" tIns="0" rIns="0" bIns="0" rtlCol="0" anchor="b"/>
-          <a:lstStyle/>
-          <a:p>
-            <a:pPr indent="0" marL="0">
-              <a:buNone/>
-            </a:pPr>
+        </p:spPr>
+        <p:txBody>
+          <a:bodyPr wrap="none" lIns="0">
+            <a:spAutoFit/>
+          </a:bodyPr>
+          <a:lstStyle/>
+          <a:p>
             <a:r>
-              <a:rPr lang="en-US" sz="3000" b="1" dirty="0">
+              <a:rPr sz="1000" i="1">
                 <a:solidFill>
-                  <a:schemeClr val="accent1"/>
+                  <a:srgbClr val="9A9A9A"/>
                 </a:solidFill>
-                <a:latin typeface="Arial" pitchFamily="34" charset="0"/>
-                <a:ea typeface="Arial" pitchFamily="34" charset="-122"/>
-                <a:cs typeface="Arial" pitchFamily="34" charset="-120"/>
               </a:rPr>
-              <a:t>+133%</a:t>
+              <a:t>Vendas mensais corrigidas pela inflação, jan/2017 a ago/2018 · cinza 2017, rosa 2018</a:t>
             </a:r>
-            <a:endParaRPr lang="en-US" sz="3000" dirty="0"/>
-          </a:p>
-        </p:txBody>
-      </p:sp>
-      <p:sp>
-        <p:nvSpPr>
-          <p:cNvPr id="8" name="capa_txt0"/>
-          <p:cNvSpPr txBox="1"/>
-          <p:nvPr/>
-        </p:nvSpPr>
-        <p:spPr>
-          <a:xfrm>
-            <a:off x="9125712" y="2148840"/>
-            <a:ext cx="2286000" cy="365760"/>
-          </a:xfrm>
-          <a:prstGeom prst="rect">
-            <a:avLst/>
-          </a:prstGeom>
-          <a:noFill/>
-          <a:ln/>
-        </p:spPr>
-        <p:txBody>
-          <a:bodyPr wrap="square" lIns="0" tIns="0" rIns="0" bIns="0" rtlCol="0" anchor="ctr"/>
-          <a:lstStyle/>
-          <a:p>
-            <a:pPr indent="0" marL="0">
-              <a:buNone/>
-            </a:pPr>
-            <a:r>
-              <a:rPr lang="en-US" sz="1300" dirty="0">
-                <a:solidFill>
-                  <a:schemeClr val="bg1"/>
-                </a:solidFill>
-                <a:latin typeface="Calibri" pitchFamily="34" charset="0"/>
-                <a:ea typeface="Calibri" pitchFamily="34" charset="-122"/>
-                <a:cs typeface="Calibri" pitchFamily="34" charset="-120"/>
-              </a:rPr>
-              <a:t>receita real em um ano</a:t>
-            </a:r>
-            <a:endParaRPr lang="en-US" sz="1300" dirty="0"/>
-          </a:p>
-        </p:txBody>
-      </p:sp>
-      <p:sp>
-        <p:nvSpPr>
-          <p:cNvPr id="9" name="capa_card1"/>
-          <p:cNvSpPr/>
-          <p:nvPr/>
-        </p:nvSpPr>
-        <p:spPr>
-          <a:xfrm>
-            <a:off x="8915400" y="2880360"/>
-            <a:ext cx="2651760" cy="1234440"/>
-          </a:xfrm>
-          <a:prstGeom prst="roundRect">
-            <a:avLst>
-              <a:gd name="adj" fmla="val 8889"/>
-            </a:avLst>
-          </a:prstGeom>
-          <a:solidFill>
-            <a:schemeClr val="tx2"/>
-          </a:solidFill>
-          <a:ln w="12700">
-            <a:solidFill>
-              <a:schemeClr val="tx2"/>
-            </a:solidFill>
-            <a:prstDash val="solid"/>
-          </a:ln>
-        </p:spPr>
-        <p:txBody>
-          <a:bodyPr/>
-          <a:p/>
-        </p:txBody>
-      </p:sp>
-      <p:sp>
-        <p:nvSpPr>
-          <p:cNvPr id="10" name="capa_num1"/>
-          <p:cNvSpPr txBox="1"/>
-          <p:nvPr/>
-        </p:nvSpPr>
-        <p:spPr>
-          <a:xfrm>
-            <a:off x="9125712" y="2990088"/>
-            <a:ext cx="2286000" cy="594360"/>
-          </a:xfrm>
-          <a:prstGeom prst="rect">
-            <a:avLst/>
-          </a:prstGeom>
-          <a:noFill/>
-          <a:ln/>
-        </p:spPr>
-        <p:txBody>
-          <a:bodyPr wrap="square" lIns="0" tIns="0" rIns="0" bIns="0" rtlCol="0" anchor="b"/>
-          <a:lstStyle/>
-          <a:p>
-            <a:pPr indent="0" marL="0">
-              <a:buNone/>
-            </a:pPr>
-            <a:r>
-              <a:rPr lang="en-US" sz="3000" b="1" dirty="0">
-                <a:solidFill>
-                  <a:schemeClr val="accent1"/>
-                </a:solidFill>
-                <a:latin typeface="Arial" pitchFamily="34" charset="0"/>
-                <a:ea typeface="Arial" pitchFamily="34" charset="-122"/>
-                <a:cs typeface="Arial" pitchFamily="34" charset="-120"/>
-              </a:rPr>
-              <a:t>R$ 1,1 mi</a:t>
-            </a:r>
-            <a:endParaRPr lang="en-US" sz="3000" dirty="0"/>
-          </a:p>
-        </p:txBody>
-      </p:sp>
-      <p:sp>
-        <p:nvSpPr>
-          <p:cNvPr id="11" name="capa_txt1"/>
-          <p:cNvSpPr txBox="1"/>
-          <p:nvPr/>
-        </p:nvSpPr>
-        <p:spPr>
-          <a:xfrm>
-            <a:off x="9125712" y="3611880"/>
-            <a:ext cx="2286000" cy="365760"/>
-          </a:xfrm>
-          <a:prstGeom prst="rect">
-            <a:avLst/>
-          </a:prstGeom>
-          <a:noFill/>
-          <a:ln/>
-        </p:spPr>
-        <p:txBody>
-          <a:bodyPr wrap="square" lIns="0" tIns="0" rIns="0" bIns="0" rtlCol="0" anchor="ctr"/>
-          <a:lstStyle/>
-          <a:p>
-            <a:pPr indent="0" marL="0">
-              <a:buNone/>
-            </a:pPr>
-            <a:r>
-              <a:rPr lang="en-US" sz="1300" dirty="0">
-                <a:solidFill>
-                  <a:schemeClr val="bg1"/>
-                </a:solidFill>
-                <a:latin typeface="Calibri" pitchFamily="34" charset="0"/>
-                <a:ea typeface="Calibri" pitchFamily="34" charset="-122"/>
-                <a:cs typeface="Calibri" pitchFamily="34" charset="-120"/>
-              </a:rPr>
-              <a:t>por mês, parada em 2018</a:t>
-            </a:r>
-            <a:endParaRPr lang="en-US" sz="1300" dirty="0"/>
-          </a:p>
-        </p:txBody>
-      </p:sp>
-      <p:sp>
-        <p:nvSpPr>
-          <p:cNvPr id="12" name="capa_card2"/>
-          <p:cNvSpPr/>
-          <p:nvPr/>
-        </p:nvSpPr>
-        <p:spPr>
-          <a:xfrm>
-            <a:off x="8915400" y="4343400"/>
-            <a:ext cx="2651760" cy="1234440"/>
-          </a:xfrm>
-          <a:prstGeom prst="roundRect">
-            <a:avLst>
-              <a:gd name="adj" fmla="val 8889"/>
-            </a:avLst>
-          </a:prstGeom>
-          <a:solidFill>
-            <a:schemeClr val="tx2"/>
-          </a:solidFill>
-          <a:ln w="12700">
-            <a:solidFill>
-              <a:schemeClr val="tx2"/>
-            </a:solidFill>
-            <a:prstDash val="solid"/>
-          </a:ln>
-        </p:spPr>
-        <p:txBody>
-          <a:bodyPr/>
-          <a:p/>
-        </p:txBody>
-      </p:sp>
-      <p:sp>
-        <p:nvSpPr>
-          <p:cNvPr id="13" name="capa_num2"/>
-          <p:cNvSpPr txBox="1"/>
-          <p:nvPr/>
-        </p:nvSpPr>
-        <p:spPr>
-          <a:xfrm>
-            <a:off x="9125712" y="4453128"/>
-            <a:ext cx="2286000" cy="594360"/>
-          </a:xfrm>
-          <a:prstGeom prst="rect">
-            <a:avLst/>
-          </a:prstGeom>
-          <a:noFill/>
-          <a:ln/>
-        </p:spPr>
-        <p:txBody>
-          <a:bodyPr wrap="square" lIns="0" tIns="0" rIns="0" bIns="0" rtlCol="0" anchor="b"/>
-          <a:lstStyle/>
-          <a:p>
-            <a:pPr indent="0" marL="0">
-              <a:buNone/>
-            </a:pPr>
-            <a:r>
-              <a:rPr lang="en-US" sz="3000" b="1" dirty="0">
-                <a:solidFill>
-                  <a:schemeClr val="accent1"/>
-                </a:solidFill>
-                <a:latin typeface="Arial" pitchFamily="34" charset="0"/>
-                <a:ea typeface="Arial" pitchFamily="34" charset="-122"/>
-                <a:cs typeface="Arial" pitchFamily="34" charset="-120"/>
-              </a:rPr>
-              <a:t>2 em 100</a:t>
-            </a:r>
-            <a:endParaRPr lang="en-US" sz="3000" dirty="0"/>
-          </a:p>
-        </p:txBody>
-      </p:sp>
-      <p:sp>
-        <p:nvSpPr>
-          <p:cNvPr id="14" name="capa_txt2"/>
-          <p:cNvSpPr txBox="1"/>
-          <p:nvPr/>
-        </p:nvSpPr>
-        <p:spPr>
-          <a:xfrm>
-            <a:off x="9125712" y="5074920"/>
-            <a:ext cx="2286000" cy="365760"/>
-          </a:xfrm>
-          <a:prstGeom prst="rect">
-            <a:avLst/>
-          </a:prstGeom>
-          <a:noFill/>
-          <a:ln/>
-        </p:spPr>
-        <p:txBody>
-          <a:bodyPr wrap="square" lIns="0" tIns="0" rIns="0" bIns="0" rtlCol="0" anchor="ctr"/>
-          <a:lstStyle/>
-          <a:p>
-            <a:pPr indent="0" marL="0">
-              <a:buNone/>
-            </a:pPr>
-            <a:r>
-              <a:rPr lang="en-US" sz="1300" dirty="0">
-                <a:solidFill>
-                  <a:schemeClr val="bg1"/>
-                </a:solidFill>
-                <a:latin typeface="Calibri" pitchFamily="34" charset="0"/>
-                <a:ea typeface="Calibri" pitchFamily="34" charset="-122"/>
-                <a:cs typeface="Calibri" pitchFamily="34" charset="-120"/>
-              </a:rPr>
-              <a:t>clientes voltam a comprar</a:t>
-            </a:r>
-            <a:endParaRPr lang="en-US" sz="1300" dirty="0"/>
           </a:p>
         </p:txBody>
       </p:sp>

</xml_diff>